<commit_message>
Align workshop with enterprise sandbox and security policies
- Remove dontAsk from permissionMode docs (cheatsheet, exercises, slides)
- Exercise 7: add sandbox/demo-only note, GITHUB_TOKEN security reminder
- Exercise 8: add branch workflow (create branch, commit+push, open PR)
- Setup instructions: note to run curl in regular terminal, not Claude
- Regenerate slides.pptx with all changes
</commit_message>
<xml_diff>
--- a/slides.pptx
+++ b/slides.pptx
@@ -8380,7 +8380,7 @@
                         </a:defRPr>
                       </a:pPr>
                       <a:r>
-                        <a:t>default, plan, acceptEdits, dontAsk</a:t>
+                        <a:t>default, plan, acceptEdits</a:t>
                       </a:r>
                     </a:p>
                   </a:txBody>
@@ -8620,6 +8620,51 @@
               </a:defRPr>
             </a:pPr>
             <a:r>
+              <a:t>Note: External MCP servers require network access — may be</a:t>
+            </a:r>
+          </a:p>
+          <a:p>
+            <a:pPr>
+              <a:spcBef>
+                <a:spcPts val="800"/>
+              </a:spcBef>
+              <a:defRPr sz="1800" b="0">
+                <a:solidFill>
+                  <a:srgbClr val="E0E0E0"/>
+                </a:solidFill>
+                <a:latin typeface="Calibri"/>
+              </a:defRPr>
+            </a:pPr>
+            <a:r>
+              <a:t>restricted by sandbox policies. Check your org's settings.</a:t>
+            </a:r>
+          </a:p>
+          <a:p>
+            <a:pPr>
+              <a:spcBef>
+                <a:spcPts val="800"/>
+              </a:spcBef>
+              <a:defRPr sz="1800" b="0">
+                <a:solidFill>
+                  <a:srgbClr val="E0E0E0"/>
+                </a:solidFill>
+                <a:latin typeface="Calibri"/>
+              </a:defRPr>
+            </a:pPr>
+          </a:p>
+          <a:p>
+            <a:pPr>
+              <a:spcBef>
+                <a:spcPts val="800"/>
+              </a:spcBef>
+              <a:defRPr sz="1800" b="0">
+                <a:solidFill>
+                  <a:srgbClr val="E0E0E0"/>
+                </a:solidFill>
+                <a:latin typeface="Calibri"/>
+              </a:defRPr>
+            </a:pPr>
+            <a:r>
               <a:t>.mcp.json         — Project (shared via git)</a:t>
             </a:r>
           </a:p>
@@ -8950,7 +8995,7 @@
               </a:defRPr>
             </a:pPr>
             <a:r>
-              <a:t>1. Read existing code (Grep, Read)</a:t>
+              <a:t>1. Branch — create a feature branch</a:t>
             </a:r>
           </a:p>
           <a:p>
@@ -8966,7 +9011,7 @@
               </a:defRPr>
             </a:pPr>
             <a:r>
-              <a:t>2. Plan the approach (may use Plan agent)</a:t>
+              <a:t>2. Read existing code (Grep, Read)</a:t>
             </a:r>
           </a:p>
           <a:p>
@@ -8982,7 +9027,7 @@
               </a:defRPr>
             </a:pPr>
             <a:r>
-              <a:t>3. Edit database.py (hook: auto-formats)</a:t>
+              <a:t>3. Plan the approach (may use Plan agent)</a:t>
             </a:r>
           </a:p>
           <a:p>
@@ -8998,7 +9043,7 @@
               </a:defRPr>
             </a:pPr>
             <a:r>
-              <a:t>4. Edit tasks.py (hook: auto-formats)</a:t>
+              <a:t>4. Edit database.py (hook: auto-formats)</a:t>
             </a:r>
           </a:p>
           <a:p>
@@ -9014,7 +9059,7 @@
               </a:defRPr>
             </a:pPr>
             <a:r>
-              <a:t>5. Write tests</a:t>
+              <a:t>5. Edit tasks.py (hook: auto-formats)</a:t>
             </a:r>
           </a:p>
           <a:p>
@@ -9030,7 +9075,7 @@
               </a:defRPr>
             </a:pPr>
             <a:r>
-              <a:t>6. Run tests (Bash)</a:t>
+              <a:t>6. Write tests</a:t>
             </a:r>
           </a:p>
           <a:p>
@@ -9046,7 +9091,7 @@
               </a:defRPr>
             </a:pPr>
             <a:r>
-              <a:t>7. Commit changes</a:t>
+              <a:t>7. Run tests (Bash)</a:t>
             </a:r>
           </a:p>
           <a:p>
@@ -9061,6 +9106,9 @@
                 <a:latin typeface="Calibri"/>
               </a:defRPr>
             </a:pPr>
+            <a:r>
+              <a:t>8. Commit &amp; push — then open a PR for review</a:t>
+            </a:r>
           </a:p>
           <a:p>
             <a:pPr>
@@ -9074,8 +9122,21 @@
                 <a:latin typeface="Calibri"/>
               </a:defRPr>
             </a:pPr>
-            <a:r>
-              <a:t>CLAUDE.md conventions + hooks + multi-file coordination</a:t>
+          </a:p>
+          <a:p>
+            <a:pPr>
+              <a:spcBef>
+                <a:spcPts val="800"/>
+              </a:spcBef>
+              <a:defRPr sz="1800" b="0">
+                <a:solidFill>
+                  <a:srgbClr val="E0E0E0"/>
+                </a:solidFill>
+                <a:latin typeface="Calibri"/>
+              </a:defRPr>
+            </a:pPr>
+            <a:r>
+              <a:t>Branch workflow + CLAUDE.md conventions + hooks + coordination</a:t>
             </a:r>
           </a:p>
         </p:txBody>

</xml_diff>

<commit_message>
Update content and slides
</commit_message>
<xml_diff>
--- a/slides.pptx
+++ b/slides.pptx
@@ -37,6 +37,10 @@
     <p:sldId id="285" r:id="rId36"/>
     <p:sldId id="286" r:id="rId37"/>
     <p:sldId id="287" r:id="rId38"/>
+    <p:sldId id="288" r:id="rId39"/>
+    <p:sldId id="289" r:id="rId40"/>
+    <p:sldId id="290" r:id="rId41"/>
+    <p:sldId id="291" r:id="rId42"/>
   </p:sldIdLst>
   <p:sldSz cx="9144000" cy="6858000" type="screen4x3"/>
   <p:notesSz cx="6858000" cy="9144000"/>
@@ -3184,7 +3188,7 @@
             <a:br/>
             <a:br/>
             <a:r>
-              <a:t>~85 minutes  |  8 exercises  |  Live coding</a:t>
+              <a:t>~95 minutes  |  9 exercises  |  Live coding</a:t>
             </a:r>
           </a:p>
         </p:txBody>
@@ -6061,7 +6065,7 @@
                         </a:defRPr>
                       </a:pPr>
                       <a:r>
-                        <a:t>Subagents, context, real-world workflow</a:t>
+                        <a:t>Subagents, MCP, context management, real-world workflow</a:t>
                       </a:r>
                     </a:p>
                   </a:txBody>
@@ -6085,7 +6089,7 @@
                         </a:defRPr>
                       </a:pPr>
                       <a:r>
-                        <a:t>15 min</a:t>
+                        <a:t>20 min</a:t>
                       </a:r>
                     </a:p>
                   </a:txBody>
@@ -8552,7 +8556,7 @@
               </a:defRPr>
             </a:pPr>
             <a:r>
-              <a:t>Exercise 7 — MCP Servers</a:t>
+              <a:t>This Project's Agents</a:t>
             </a:r>
           </a:p>
         </p:txBody>
@@ -8591,97 +8595,7 @@
               </a:defRPr>
             </a:pPr>
             <a:r>
-              <a:t>Connect Claude to external tools and services</a:t>
-            </a:r>
-          </a:p>
-          <a:p>
-            <a:pPr>
-              <a:spcBef>
-                <a:spcPts val="800"/>
-              </a:spcBef>
-              <a:defRPr sz="1800" b="0">
-                <a:solidFill>
-                  <a:srgbClr val="E0E0E0"/>
-                </a:solidFill>
-                <a:latin typeface="Calibri"/>
-              </a:defRPr>
-            </a:pPr>
-          </a:p>
-          <a:p>
-            <a:pPr>
-              <a:spcBef>
-                <a:spcPts val="800"/>
-              </a:spcBef>
-              <a:defRPr sz="1800" b="0">
-                <a:solidFill>
-                  <a:srgbClr val="E0E0E0"/>
-                </a:solidFill>
-                <a:latin typeface="Calibri"/>
-              </a:defRPr>
-            </a:pPr>
-            <a:r>
-              <a:t>Note: External MCP servers require network access — may be</a:t>
-            </a:r>
-          </a:p>
-          <a:p>
-            <a:pPr>
-              <a:spcBef>
-                <a:spcPts val="800"/>
-              </a:spcBef>
-              <a:defRPr sz="1800" b="0">
-                <a:solidFill>
-                  <a:srgbClr val="E0E0E0"/>
-                </a:solidFill>
-                <a:latin typeface="Calibri"/>
-              </a:defRPr>
-            </a:pPr>
-            <a:r>
-              <a:t>restricted by sandbox policies. Check your org's settings.</a:t>
-            </a:r>
-          </a:p>
-          <a:p>
-            <a:pPr>
-              <a:spcBef>
-                <a:spcPts val="800"/>
-              </a:spcBef>
-              <a:defRPr sz="1800" b="0">
-                <a:solidFill>
-                  <a:srgbClr val="E0E0E0"/>
-                </a:solidFill>
-                <a:latin typeface="Calibri"/>
-              </a:defRPr>
-            </a:pPr>
-          </a:p>
-          <a:p>
-            <a:pPr>
-              <a:spcBef>
-                <a:spcPts val="800"/>
-              </a:spcBef>
-              <a:defRPr sz="1800" b="0">
-                <a:solidFill>
-                  <a:srgbClr val="E0E0E0"/>
-                </a:solidFill>
-                <a:latin typeface="Calibri"/>
-              </a:defRPr>
-            </a:pPr>
-            <a:r>
-              <a:t>.mcp.json         — Project (shared via git)</a:t>
-            </a:r>
-          </a:p>
-          <a:p>
-            <a:pPr>
-              <a:spcBef>
-                <a:spcPts val="800"/>
-              </a:spcBef>
-              <a:defRPr sz="1800" b="0">
-                <a:solidFill>
-                  <a:srgbClr val="E0E0E0"/>
-                </a:solidFill>
-                <a:latin typeface="Calibri"/>
-              </a:defRPr>
-            </a:pPr>
-            <a:r>
-              <a:t>~/.claude.json    — User / local (personal)</a:t>
+              <a:t>Researcher — fast, cheap, read-only</a:t>
             </a:r>
           </a:p>
         </p:txBody>
@@ -8721,7 +8635,7 @@
               </a:defRPr>
             </a:pPr>
             <a:r>
-              <a:t>// .mcp.json</a:t>
+              <a:t>model: haiku</a:t>
             </a:r>
           </a:p>
           <a:p>
@@ -8737,7 +8651,7 @@
               </a:defRPr>
             </a:pPr>
             <a:r>
-              <a:t>{</a:t>
+              <a:t>effort: low</a:t>
             </a:r>
           </a:p>
           <a:p>
@@ -8753,7 +8667,7 @@
               </a:defRPr>
             </a:pPr>
             <a:r>
-              <a:t>  "mcpServers": {</a:t>
+              <a:t>maxTurns: 10</a:t>
             </a:r>
           </a:p>
           <a:p>
@@ -8769,7 +8683,7 @@
               </a:defRPr>
             </a:pPr>
             <a:r>
-              <a:t>    "github": {</a:t>
+              <a:t>memory: project         # learns across sessions</a:t>
             </a:r>
           </a:p>
           <a:p>
@@ -8785,7 +8699,7 @@
               </a:defRPr>
             </a:pPr>
             <a:r>
-              <a:t>      "type": "stdio",</a:t>
+              <a:t>disallowedTools: Write, Edit, Bash</a:t>
             </a:r>
           </a:p>
           <a:p>
@@ -8800,9 +8714,6 @@
                 <a:latin typeface="Consolas"/>
               </a:defRPr>
             </a:pPr>
-            <a:r>
-              <a:t>      "command": "npx",</a:t>
-            </a:r>
           </a:p>
           <a:p>
             <a:pPr>
@@ -8817,7 +8728,7 @@
               </a:defRPr>
             </a:pPr>
             <a:r>
-              <a:t>      "args": ["-y", "@anthropic-ai/github-mcp"]</a:t>
+              <a:t># Reviewer — thorough code review</a:t>
             </a:r>
           </a:p>
           <a:p>
@@ -8833,7 +8744,7 @@
               </a:defRPr>
             </a:pPr>
             <a:r>
-              <a:t>    }</a:t>
+              <a:t>model: sonnet</a:t>
             </a:r>
           </a:p>
           <a:p>
@@ -8849,7 +8760,7 @@
               </a:defRPr>
             </a:pPr>
             <a:r>
-              <a:t>  }</a:t>
+              <a:t>effort: high</a:t>
             </a:r>
           </a:p>
           <a:p>
@@ -8865,7 +8776,39 @@
               </a:defRPr>
             </a:pPr>
             <a:r>
-              <a:t>}</a:t>
+              <a:t>maxTurns: 15</a:t>
+            </a:r>
+          </a:p>
+          <a:p>
+            <a:pPr>
+              <a:spcBef>
+                <a:spcPts val="200"/>
+              </a:spcBef>
+              <a:defRPr sz="1400">
+                <a:solidFill>
+                  <a:srgbClr val="E8C47C"/>
+                </a:solidFill>
+                <a:latin typeface="Consolas"/>
+              </a:defRPr>
+            </a:pPr>
+            <a:r>
+              <a:t>skills: review          # preloads /review skill</a:t>
+            </a:r>
+          </a:p>
+          <a:p>
+            <a:pPr>
+              <a:spcBef>
+                <a:spcPts val="200"/>
+              </a:spcBef>
+              <a:defRPr sz="1400">
+                <a:solidFill>
+                  <a:srgbClr val="E8C47C"/>
+                </a:solidFill>
+                <a:latin typeface="Consolas"/>
+              </a:defRPr>
+            </a:pPr>
+            <a:r>
+              <a:t>disallowedTools: Write, Edit</a:t>
             </a:r>
           </a:p>
         </p:txBody>
@@ -8927,7 +8870,7 @@
               </a:defRPr>
             </a:pPr>
             <a:r>
-              <a:t>Exercise 8 — Real-World Workflow</a:t>
+              <a:t>Exercise 7 — MCP Servers</a:t>
             </a:r>
           </a:p>
         </p:txBody>
@@ -8966,7 +8909,7 @@
               </a:defRPr>
             </a:pPr>
             <a:r>
-              <a:t>Putting it all together:</a:t>
+              <a:t>Connect Claude to external tools and services</a:t>
             </a:r>
           </a:p>
           <a:p>
@@ -8981,6 +8924,9 @@
                 <a:latin typeface="Calibri"/>
               </a:defRPr>
             </a:pPr>
+            <a:r>
+              <a:t>External MCP servers require network access — may be restricted by sandbox policies</a:t>
+            </a:r>
           </a:p>
           <a:p>
             <a:pPr>
@@ -8994,9 +8940,6 @@
                 <a:latin typeface="Calibri"/>
               </a:defRPr>
             </a:pPr>
-            <a:r>
-              <a:t>1. Branch — create a feature branch</a:t>
-            </a:r>
           </a:p>
           <a:p>
             <a:pPr>
@@ -9011,132 +8954,7 @@
               </a:defRPr>
             </a:pPr>
             <a:r>
-              <a:t>2. Read existing code (Grep, Read)</a:t>
-            </a:r>
-          </a:p>
-          <a:p>
-            <a:pPr>
-              <a:spcBef>
-                <a:spcPts val="800"/>
-              </a:spcBef>
-              <a:defRPr sz="1800" b="0">
-                <a:solidFill>
-                  <a:srgbClr val="E0E0E0"/>
-                </a:solidFill>
-                <a:latin typeface="Calibri"/>
-              </a:defRPr>
-            </a:pPr>
-            <a:r>
-              <a:t>3. Plan the approach (may use Plan agent)</a:t>
-            </a:r>
-          </a:p>
-          <a:p>
-            <a:pPr>
-              <a:spcBef>
-                <a:spcPts val="800"/>
-              </a:spcBef>
-              <a:defRPr sz="1800" b="0">
-                <a:solidFill>
-                  <a:srgbClr val="E0E0E0"/>
-                </a:solidFill>
-                <a:latin typeface="Calibri"/>
-              </a:defRPr>
-            </a:pPr>
-            <a:r>
-              <a:t>4. Edit database.py (hook: auto-formats)</a:t>
-            </a:r>
-          </a:p>
-          <a:p>
-            <a:pPr>
-              <a:spcBef>
-                <a:spcPts val="800"/>
-              </a:spcBef>
-              <a:defRPr sz="1800" b="0">
-                <a:solidFill>
-                  <a:srgbClr val="E0E0E0"/>
-                </a:solidFill>
-                <a:latin typeface="Calibri"/>
-              </a:defRPr>
-            </a:pPr>
-            <a:r>
-              <a:t>5. Edit tasks.py (hook: auto-formats)</a:t>
-            </a:r>
-          </a:p>
-          <a:p>
-            <a:pPr>
-              <a:spcBef>
-                <a:spcPts val="800"/>
-              </a:spcBef>
-              <a:defRPr sz="1800" b="0">
-                <a:solidFill>
-                  <a:srgbClr val="E0E0E0"/>
-                </a:solidFill>
-                <a:latin typeface="Calibri"/>
-              </a:defRPr>
-            </a:pPr>
-            <a:r>
-              <a:t>6. Write tests</a:t>
-            </a:r>
-          </a:p>
-          <a:p>
-            <a:pPr>
-              <a:spcBef>
-                <a:spcPts val="800"/>
-              </a:spcBef>
-              <a:defRPr sz="1800" b="0">
-                <a:solidFill>
-                  <a:srgbClr val="E0E0E0"/>
-                </a:solidFill>
-                <a:latin typeface="Calibri"/>
-              </a:defRPr>
-            </a:pPr>
-            <a:r>
-              <a:t>7. Run tests (Bash)</a:t>
-            </a:r>
-          </a:p>
-          <a:p>
-            <a:pPr>
-              <a:spcBef>
-                <a:spcPts val="800"/>
-              </a:spcBef>
-              <a:defRPr sz="1800" b="0">
-                <a:solidFill>
-                  <a:srgbClr val="E0E0E0"/>
-                </a:solidFill>
-                <a:latin typeface="Calibri"/>
-              </a:defRPr>
-            </a:pPr>
-            <a:r>
-              <a:t>8. Commit &amp; push — then open a PR for review</a:t>
-            </a:r>
-          </a:p>
-          <a:p>
-            <a:pPr>
-              <a:spcBef>
-                <a:spcPts val="800"/>
-              </a:spcBef>
-              <a:defRPr sz="1800" b="0">
-                <a:solidFill>
-                  <a:srgbClr val="E0E0E0"/>
-                </a:solidFill>
-                <a:latin typeface="Calibri"/>
-              </a:defRPr>
-            </a:pPr>
-          </a:p>
-          <a:p>
-            <a:pPr>
-              <a:spcBef>
-                <a:spcPts val="800"/>
-              </a:spcBef>
-              <a:defRPr sz="1800" b="0">
-                <a:solidFill>
-                  <a:srgbClr val="E0E0E0"/>
-                </a:solidFill>
-                <a:latin typeface="Calibri"/>
-              </a:defRPr>
-            </a:pPr>
-            <a:r>
-              <a:t>Branch workflow + CLAUDE.md conventions + hooks + coordination</a:t>
+              <a:t>Two transport types:</a:t>
             </a:r>
           </a:p>
         </p:txBody>
@@ -9176,7 +8994,7 @@
               </a:defRPr>
             </a:pPr>
             <a:r>
-              <a:t>"Add a search endpoint for tasks — case-insensitive</a:t>
+              <a:t>// HTTP (remote endpoint)</a:t>
             </a:r>
           </a:p>
           <a:p>
@@ -9192,7 +9010,7 @@
               </a:defRPr>
             </a:pPr>
             <a:r>
-              <a:t> substring match on title and description via query</a:t>
+              <a:t>{ "type": "http", "url": "https://api.example.com/mcp",</a:t>
             </a:r>
           </a:p>
           <a:p>
@@ -9208,7 +9026,68 @@
               </a:defRPr>
             </a:pPr>
             <a:r>
-              <a:t> param 'q'. Update database, endpoint, and tests."</a:t>
+              <a:t>  "headers": { "Authorization": "Bearer ${TOKEN}" } }</a:t>
+            </a:r>
+          </a:p>
+          <a:p>
+            <a:pPr>
+              <a:spcBef>
+                <a:spcPts val="200"/>
+              </a:spcBef>
+              <a:defRPr sz="1400">
+                <a:solidFill>
+                  <a:srgbClr val="E8C47C"/>
+                </a:solidFill>
+                <a:latin typeface="Consolas"/>
+              </a:defRPr>
+            </a:pPr>
+          </a:p>
+          <a:p>
+            <a:pPr>
+              <a:spcBef>
+                <a:spcPts val="200"/>
+              </a:spcBef>
+              <a:defRPr sz="1400">
+                <a:solidFill>
+                  <a:srgbClr val="E8C47C"/>
+                </a:solidFill>
+                <a:latin typeface="Consolas"/>
+              </a:defRPr>
+            </a:pPr>
+            <a:r>
+              <a:t>// stdio (local subprocess)</a:t>
+            </a:r>
+          </a:p>
+          <a:p>
+            <a:pPr>
+              <a:spcBef>
+                <a:spcPts val="200"/>
+              </a:spcBef>
+              <a:defRPr sz="1400">
+                <a:solidFill>
+                  <a:srgbClr val="E8C47C"/>
+                </a:solidFill>
+                <a:latin typeface="Consolas"/>
+              </a:defRPr>
+            </a:pPr>
+            <a:r>
+              <a:t>{ "type": "stdio", "command": "npx",</a:t>
+            </a:r>
+          </a:p>
+          <a:p>
+            <a:pPr>
+              <a:spcBef>
+                <a:spcPts val="200"/>
+              </a:spcBef>
+              <a:defRPr sz="1400">
+                <a:solidFill>
+                  <a:srgbClr val="E8C47C"/>
+                </a:solidFill>
+                <a:latin typeface="Consolas"/>
+              </a:defRPr>
+            </a:pPr>
+            <a:r>
+              <a:t>  "args": ["-y", "@modelcontextprotocol/server-filesystem", "/tmp"] }</a:t>
             </a:r>
           </a:p>
         </p:txBody>
@@ -9227,7 +9106,7 @@
     <p:bg>
       <p:bgPr>
         <a:solidFill>
-          <a:srgbClr val="0F0F1E"/>
+          <a:srgbClr val="1A1A2E"/>
         </a:solidFill>
         <a:effectLst/>
       </p:bgPr>
@@ -9247,8 +9126,8 @@
         </p:nvSpPr>
         <p:spPr>
           <a:xfrm>
-            <a:off x="914400" y="1828800"/>
-            <a:ext cx="7315200" cy="1828800"/>
+            <a:off x="548640" y="365760"/>
+            <a:ext cx="8046720" cy="731520"/>
           </a:xfrm>
           <a:prstGeom prst="rect">
             <a:avLst/>
@@ -9261,8 +9140,8 @@
           </a:bodyPr>
           <a:lstStyle/>
           <a:p>
-            <a:pPr algn="ctr">
-              <a:defRPr sz="4000" b="1">
+            <a:pPr>
+              <a:defRPr sz="3200" b="1">
                 <a:solidFill>
                   <a:srgbClr val="D4A574"/>
                 </a:solidFill>
@@ -9270,7 +9149,75 @@
               </a:defRPr>
             </a:pPr>
             <a:r>
-              <a:t>Wrap-Up</a:t>
+              <a:t>Exercise 8 — Context Management</a:t>
+            </a:r>
+          </a:p>
+        </p:txBody>
+      </p:sp>
+      <p:sp>
+        <p:nvSpPr>
+          <p:cNvPr id="3" name="TextBox 2"/>
+          <p:cNvSpPr txBox="1"/>
+          <p:nvPr/>
+        </p:nvSpPr>
+        <p:spPr>
+          <a:xfrm>
+            <a:off x="548640" y="1188720"/>
+            <a:ext cx="8046720" cy="5029200"/>
+          </a:xfrm>
+          <a:prstGeom prst="rect">
+            <a:avLst/>
+          </a:prstGeom>
+          <a:noFill/>
+        </p:spPr>
+        <p:txBody>
+          <a:bodyPr wrap="square">
+            <a:spAutoFit/>
+          </a:bodyPr>
+          <a:lstStyle/>
+          <a:p>
+            <a:pPr>
+              <a:spcBef>
+                <a:spcPts val="400"/>
+              </a:spcBef>
+              <a:defRPr sz="1800">
+                <a:solidFill>
+                  <a:srgbClr val="E0E0E0"/>
+                </a:solidFill>
+                <a:latin typeface="Calibri"/>
+              </a:defRPr>
+            </a:pPr>
+            <a:r>
+              <a:t>Keep long sessions productive</a:t>
+            </a:r>
+          </a:p>
+          <a:p>
+            <a:pPr>
+              <a:spcBef>
+                <a:spcPts val="800"/>
+              </a:spcBef>
+              <a:defRPr sz="1800" b="0">
+                <a:solidFill>
+                  <a:srgbClr val="E0E0E0"/>
+                </a:solidFill>
+                <a:latin typeface="Calibri"/>
+              </a:defRPr>
+            </a:pPr>
+          </a:p>
+          <a:p>
+            <a:pPr>
+              <a:spcBef>
+                <a:spcPts val="800"/>
+              </a:spcBef>
+              <a:defRPr sz="1800" b="0">
+                <a:solidFill>
+                  <a:srgbClr val="E0E0E0"/>
+                </a:solidFill>
+                <a:latin typeface="Calibri"/>
+              </a:defRPr>
+            </a:pPr>
+            <a:r>
+              <a:t>Claude has a ~200K token context window. It fills up fast:</a:t>
             </a:r>
           </a:p>
         </p:txBody>
@@ -9332,7 +9279,7 @@
               </a:defRPr>
             </a:pPr>
             <a:r>
-              <a:t>Quick Wins to Take Home</a:t>
+              <a:t>Monitor, Compact, Remember</a:t>
             </a:r>
           </a:p>
         </p:txBody>
@@ -9371,7 +9318,7 @@
               </a:defRPr>
             </a:pPr>
             <a:r>
-              <a:t>Today:</a:t>
+              <a:t>Check usage:</a:t>
             </a:r>
           </a:p>
           <a:p>
@@ -9387,7 +9334,7 @@
               </a:defRPr>
             </a:pPr>
             <a:r>
-              <a:t>  1. Add CLAUDE.md to your projects — biggest ROI, 5 minutes</a:t>
+              <a:t>  /context          — shows current % used</a:t>
             </a:r>
           </a:p>
           <a:p>
@@ -9416,7 +9363,7 @@
               </a:defRPr>
             </a:pPr>
             <a:r>
-              <a:t>This week:</a:t>
+              <a:t>Free up space:</a:t>
             </a:r>
           </a:p>
           <a:p>
@@ -9432,7 +9379,7 @@
               </a:defRPr>
             </a:pPr>
             <a:r>
-              <a:t>  2. Configure settings — allow pytest/git, deny rm -rf/.env</a:t>
+              <a:t>  /compact          — summarizes history (do this proactively at ~70%)</a:t>
             </a:r>
           </a:p>
           <a:p>
@@ -9448,7 +9395,7 @@
               </a:defRPr>
             </a:pPr>
             <a:r>
-              <a:t>  3. Create one skill for your most repeated workflow</a:t>
+              <a:t>  Auto-compaction triggers at ~95% — less precise, don't wait for it.</a:t>
             </a:r>
           </a:p>
           <a:p>
@@ -9477,7 +9424,7 @@
               </a:defRPr>
             </a:pPr>
             <a:r>
-              <a:t>This month:</a:t>
+              <a:t>Persist facts across sessions:</a:t>
             </a:r>
           </a:p>
           <a:p>
@@ -9493,7 +9440,7 @@
               </a:defRPr>
             </a:pPr>
             <a:r>
-              <a:t>  4. Add hooks — auto-format, secret detection</a:t>
+              <a:t>  /memory           — opens auto-memory files</a:t>
             </a:r>
           </a:p>
           <a:p>
@@ -9509,7 +9456,7 @@
               </a:defRPr>
             </a:pPr>
             <a:r>
-              <a:t>  5. Create custom agents for your team's review/research needs</a:t>
+              <a:t>  Saves to ~/.claude/projects/&lt;path&gt;/memory/MEMORY.md — loaded every session.</a:t>
             </a:r>
           </a:p>
         </p:txBody>
@@ -9782,7 +9729,7 @@
               </a:defRPr>
             </a:pPr>
             <a:r>
-              <a:t>The Configuration Landscape</a:t>
+              <a:t>Context Strategy</a:t>
             </a:r>
           </a:p>
         </p:txBody>
@@ -9797,7 +9744,7 @@
         </p:nvGraphicFramePr>
         <p:xfrm>
           <a:off x="548640" y="1280160"/>
-          <a:ext cx="8046720" cy="2880360"/>
+          <a:ext cx="8046720" cy="2468880"/>
         </p:xfrm>
         <a:graphic>
           <a:graphicData uri="http://schemas.openxmlformats.org/drawingml/2006/table">
@@ -9806,9 +9753,8 @@
                 <a:tableStyleId>{5C22544A-7EE6-4342-B048-85BDC9FD1C3A}</a:tableStyleId>
               </a:tblPr>
               <a:tblGrid>
-                <a:gridCol w="2682240"/>
-                <a:gridCol w="2682240"/>
-                <a:gridCol w="2682240"/>
+                <a:gridCol w="4023360"/>
+                <a:gridCol w="4023360"/>
               </a:tblGrid>
               <a:tr h="411480">
                 <a:tc>
@@ -9825,7 +9771,7 @@
                         </a:defRPr>
                       </a:pPr>
                       <a:r>
-                        <a:t>Feature</a:t>
+                        <a:t>Situation</a:t>
                       </a:r>
                     </a:p>
                   </a:txBody>
@@ -9849,31 +9795,7 @@
                         </a:defRPr>
                       </a:pPr>
                       <a:r>
-                        <a:t>File</a:t>
-                      </a:r>
-                    </a:p>
-                  </a:txBody>
-                  <a:tcPr>
-                    <a:solidFill>
-                      <a:srgbClr val="2D2D44"/>
-                    </a:solidFill>
-                  </a:tcPr>
-                </a:tc>
-                <a:tc>
-                  <a:txBody>
-                    <a:bodyPr/>
-                    <a:lstStyle/>
-                    <a:p>
-                      <a:pPr>
-                        <a:defRPr sz="1400" b="1">
-                          <a:solidFill>
-                            <a:srgbClr val="D4A574"/>
-                          </a:solidFill>
-                          <a:latin typeface="Calibri"/>
-                        </a:defRPr>
-                      </a:pPr>
-                      <a:r>
-                        <a:t>Guides vs Enforces</a:t>
+                        <a:t>Action</a:t>
                       </a:r>
                     </a:p>
                   </a:txBody>
@@ -9899,7 +9821,7 @@
                         </a:defRPr>
                       </a:pPr>
                       <a:r>
-                        <a:t>CLAUDE.md</a:t>
+                        <a:t>Between major tasks</a:t>
                       </a:r>
                     </a:p>
                   </a:txBody>
@@ -9923,31 +9845,7 @@
                         </a:defRPr>
                       </a:pPr>
                       <a:r>
-                        <a:t>./CLAUDE.md</a:t>
-                      </a:r>
-                    </a:p>
-                  </a:txBody>
-                  <a:tcPr>
-                    <a:solidFill>
-                      <a:srgbClr val="1E1E36"/>
-                    </a:solidFill>
-                  </a:tcPr>
-                </a:tc>
-                <a:tc>
-                  <a:txBody>
-                    <a:bodyPr/>
-                    <a:lstStyle/>
-                    <a:p>
-                      <a:pPr>
-                        <a:defRPr sz="1300">
-                          <a:solidFill>
-                            <a:srgbClr val="E0E0E0"/>
-                          </a:solidFill>
-                          <a:latin typeface="Calibri"/>
-                        </a:defRPr>
-                      </a:pPr>
-                      <a:r>
-                        <a:t>Guides</a:t>
+                        <a:t>/compact to clear noise</a:t>
                       </a:r>
                     </a:p>
                   </a:txBody>
@@ -9973,7 +9871,7 @@
                         </a:defRPr>
                       </a:pPr>
                       <a:r>
-                        <a:t>Settings</a:t>
+                        <a:t>Context &gt; 70%</a:t>
                       </a:r>
                     </a:p>
                   </a:txBody>
@@ -9997,31 +9895,7 @@
                         </a:defRPr>
                       </a:pPr>
                       <a:r>
-                        <a:t>.claude/settings.json</a:t>
-                      </a:r>
-                    </a:p>
-                  </a:txBody>
-                  <a:tcPr>
-                    <a:solidFill>
-                      <a:srgbClr val="1E1E36"/>
-                    </a:solidFill>
-                  </a:tcPr>
-                </a:tc>
-                <a:tc>
-                  <a:txBody>
-                    <a:bodyPr/>
-                    <a:lstStyle/>
-                    <a:p>
-                      <a:pPr>
-                        <a:defRPr sz="1300">
-                          <a:solidFill>
-                            <a:srgbClr val="E0E0E0"/>
-                          </a:solidFill>
-                          <a:latin typeface="Calibri"/>
-                        </a:defRPr>
-                      </a:pPr>
-                      <a:r>
-                        <a:t>Enforces</a:t>
+                        <a:t>/compact proactively</a:t>
                       </a:r>
                     </a:p>
                   </a:txBody>
@@ -10047,7 +9921,7 @@
                         </a:defRPr>
                       </a:pPr>
                       <a:r>
-                        <a:t>Hooks</a:t>
+                        <a:t>Context &gt; 90%</a:t>
                       </a:r>
                     </a:p>
                   </a:txBody>
@@ -10071,31 +9945,7 @@
                         </a:defRPr>
                       </a:pPr>
                       <a:r>
-                        <a:t>In settings.json</a:t>
-                      </a:r>
-                    </a:p>
-                  </a:txBody>
-                  <a:tcPr>
-                    <a:solidFill>
-                      <a:srgbClr val="1E1E36"/>
-                    </a:solidFill>
-                  </a:tcPr>
-                </a:tc>
-                <a:tc>
-                  <a:txBody>
-                    <a:bodyPr/>
-                    <a:lstStyle/>
-                    <a:p>
-                      <a:pPr>
-                        <a:defRPr sz="1300">
-                          <a:solidFill>
-                            <a:srgbClr val="E0E0E0"/>
-                          </a:solidFill>
-                          <a:latin typeface="Calibri"/>
-                        </a:defRPr>
-                      </a:pPr>
-                      <a:r>
-                        <a:t>Enforces</a:t>
+                        <a:t>New session + claude --continue</a:t>
                       </a:r>
                     </a:p>
                   </a:txBody>
@@ -10121,7 +9971,7 @@
                         </a:defRPr>
                       </a:pPr>
                       <a:r>
-                        <a:t>Skills</a:t>
+                        <a:t>Large read-only research</a:t>
                       </a:r>
                     </a:p>
                   </a:txBody>
@@ -10145,31 +9995,7 @@
                         </a:defRPr>
                       </a:pPr>
                       <a:r>
-                        <a:t>.claude/skills/*/SKILL.md</a:t>
-                      </a:r>
-                    </a:p>
-                  </a:txBody>
-                  <a:tcPr>
-                    <a:solidFill>
-                      <a:srgbClr val="1E1E36"/>
-                    </a:solidFill>
-                  </a:tcPr>
-                </a:tc>
-                <a:tc>
-                  <a:txBody>
-                    <a:bodyPr/>
-                    <a:lstStyle/>
-                    <a:p>
-                      <a:pPr>
-                        <a:defRPr sz="1300">
-                          <a:solidFill>
-                            <a:srgbClr val="E0E0E0"/>
-                          </a:solidFill>
-                          <a:latin typeface="Calibri"/>
-                        </a:defRPr>
-                      </a:pPr>
-                      <a:r>
-                        <a:t>Guides</a:t>
+                        <a:t>Use an Explore subagent (isolated context)</a:t>
                       </a:r>
                     </a:p>
                   </a:txBody>
@@ -10195,7 +10021,7 @@
                         </a:defRPr>
                       </a:pPr>
                       <a:r>
-                        <a:t>Agents</a:t>
+                        <a:t>Convention Claude keeps forgetting</a:t>
                       </a:r>
                     </a:p>
                   </a:txBody>
@@ -10219,105 +10045,7 @@
                         </a:defRPr>
                       </a:pPr>
                       <a:r>
-                        <a:t>.claude/agents/*.md</a:t>
-                      </a:r>
-                    </a:p>
-                  </a:txBody>
-                  <a:tcPr>
-                    <a:solidFill>
-                      <a:srgbClr val="1E1E36"/>
-                    </a:solidFill>
-                  </a:tcPr>
-                </a:tc>
-                <a:tc>
-                  <a:txBody>
-                    <a:bodyPr/>
-                    <a:lstStyle/>
-                    <a:p>
-                      <a:pPr>
-                        <a:defRPr sz="1300">
-                          <a:solidFill>
-                            <a:srgbClr val="E0E0E0"/>
-                          </a:solidFill>
-                          <a:latin typeface="Calibri"/>
-                        </a:defRPr>
-                      </a:pPr>
-                      <a:r>
-                        <a:t>Both</a:t>
-                      </a:r>
-                    </a:p>
-                  </a:txBody>
-                  <a:tcPr>
-                    <a:solidFill>
-                      <a:srgbClr val="1E1E36"/>
-                    </a:solidFill>
-                  </a:tcPr>
-                </a:tc>
-              </a:tr>
-              <a:tr h="411480">
-                <a:tc>
-                  <a:txBody>
-                    <a:bodyPr/>
-                    <a:lstStyle/>
-                    <a:p>
-                      <a:pPr>
-                        <a:defRPr sz="1300">
-                          <a:solidFill>
-                            <a:srgbClr val="E0E0E0"/>
-                          </a:solidFill>
-                          <a:latin typeface="Calibri"/>
-                        </a:defRPr>
-                      </a:pPr>
-                      <a:r>
-                        <a:t>MCP</a:t>
-                      </a:r>
-                    </a:p>
-                  </a:txBody>
-                  <a:tcPr>
-                    <a:solidFill>
-                      <a:srgbClr val="1E1E36"/>
-                    </a:solidFill>
-                  </a:tcPr>
-                </a:tc>
-                <a:tc>
-                  <a:txBody>
-                    <a:bodyPr/>
-                    <a:lstStyle/>
-                    <a:p>
-                      <a:pPr>
-                        <a:defRPr sz="1300">
-                          <a:solidFill>
-                            <a:srgbClr val="E0E0E0"/>
-                          </a:solidFill>
-                          <a:latin typeface="Calibri"/>
-                        </a:defRPr>
-                      </a:pPr>
-                      <a:r>
-                        <a:t>.mcp.json</a:t>
-                      </a:r>
-                    </a:p>
-                  </a:txBody>
-                  <a:tcPr>
-                    <a:solidFill>
-                      <a:srgbClr val="1E1E36"/>
-                    </a:solidFill>
-                  </a:tcPr>
-                </a:tc>
-                <a:tc>
-                  <a:txBody>
-                    <a:bodyPr/>
-                    <a:lstStyle/>
-                    <a:p>
-                      <a:pPr>
-                        <a:defRPr sz="1300">
-                          <a:solidFill>
-                            <a:srgbClr val="E0E0E0"/>
-                          </a:solidFill>
-                          <a:latin typeface="Calibri"/>
-                        </a:defRPr>
-                      </a:pPr>
-                      <a:r>
-                        <a:t>Extends</a:t>
+                        <a:t>Add to /memory or CLAUDE.md</a:t>
                       </a:r>
                     </a:p>
                   </a:txBody>
@@ -10389,7 +10117,412 @@
               </a:defRPr>
             </a:pPr>
             <a:r>
-              <a:t>Resources</a:t>
+              <a:t>Exercise 9 — Real-World Workflow</a:t>
+            </a:r>
+          </a:p>
+        </p:txBody>
+      </p:sp>
+      <p:sp>
+        <p:nvSpPr>
+          <p:cNvPr id="3" name="TextBox 2"/>
+          <p:cNvSpPr txBox="1"/>
+          <p:nvPr/>
+        </p:nvSpPr>
+        <p:spPr>
+          <a:xfrm>
+            <a:off x="548640" y="1188720"/>
+            <a:ext cx="8046720" cy="3200400"/>
+          </a:xfrm>
+          <a:prstGeom prst="rect">
+            <a:avLst/>
+          </a:prstGeom>
+          <a:noFill/>
+        </p:spPr>
+        <p:txBody>
+          <a:bodyPr wrap="square">
+            <a:spAutoFit/>
+          </a:bodyPr>
+          <a:lstStyle/>
+          <a:p>
+            <a:pPr>
+              <a:spcBef>
+                <a:spcPts val="400"/>
+              </a:spcBef>
+              <a:defRPr sz="1800">
+                <a:solidFill>
+                  <a:srgbClr val="E0E0E0"/>
+                </a:solidFill>
+                <a:latin typeface="Calibri"/>
+              </a:defRPr>
+            </a:pPr>
+            <a:r>
+              <a:t>Putting it all together:</a:t>
+            </a:r>
+          </a:p>
+          <a:p>
+            <a:pPr>
+              <a:spcBef>
+                <a:spcPts val="800"/>
+              </a:spcBef>
+              <a:defRPr sz="1800" b="0">
+                <a:solidFill>
+                  <a:srgbClr val="E0E0E0"/>
+                </a:solidFill>
+                <a:latin typeface="Calibri"/>
+              </a:defRPr>
+            </a:pPr>
+          </a:p>
+          <a:p>
+            <a:pPr>
+              <a:spcBef>
+                <a:spcPts val="800"/>
+              </a:spcBef>
+              <a:defRPr sz="1800" b="0">
+                <a:solidFill>
+                  <a:srgbClr val="E0E0E0"/>
+                </a:solidFill>
+                <a:latin typeface="Calibri"/>
+              </a:defRPr>
+            </a:pPr>
+            <a:r>
+              <a:t>1. Branch — create a feature branch</a:t>
+            </a:r>
+          </a:p>
+          <a:p>
+            <a:pPr>
+              <a:spcBef>
+                <a:spcPts val="800"/>
+              </a:spcBef>
+              <a:defRPr sz="1800" b="0">
+                <a:solidFill>
+                  <a:srgbClr val="E0E0E0"/>
+                </a:solidFill>
+                <a:latin typeface="Calibri"/>
+              </a:defRPr>
+            </a:pPr>
+            <a:r>
+              <a:t>2. Read existing code (Grep, Read)</a:t>
+            </a:r>
+          </a:p>
+          <a:p>
+            <a:pPr>
+              <a:spcBef>
+                <a:spcPts val="800"/>
+              </a:spcBef>
+              <a:defRPr sz="1800" b="0">
+                <a:solidFill>
+                  <a:srgbClr val="E0E0E0"/>
+                </a:solidFill>
+                <a:latin typeface="Calibri"/>
+              </a:defRPr>
+            </a:pPr>
+            <a:r>
+              <a:t>3. Plan the approach (may use Plan agent)</a:t>
+            </a:r>
+          </a:p>
+          <a:p>
+            <a:pPr>
+              <a:spcBef>
+                <a:spcPts val="800"/>
+              </a:spcBef>
+              <a:defRPr sz="1800" b="0">
+                <a:solidFill>
+                  <a:srgbClr val="E0E0E0"/>
+                </a:solidFill>
+                <a:latin typeface="Calibri"/>
+              </a:defRPr>
+            </a:pPr>
+            <a:r>
+              <a:t>4. Edit database.py (hook: auto-formats)</a:t>
+            </a:r>
+          </a:p>
+          <a:p>
+            <a:pPr>
+              <a:spcBef>
+                <a:spcPts val="800"/>
+              </a:spcBef>
+              <a:defRPr sz="1800" b="0">
+                <a:solidFill>
+                  <a:srgbClr val="E0E0E0"/>
+                </a:solidFill>
+                <a:latin typeface="Calibri"/>
+              </a:defRPr>
+            </a:pPr>
+            <a:r>
+              <a:t>5. Edit tasks.py (hook: auto-formats)</a:t>
+            </a:r>
+          </a:p>
+          <a:p>
+            <a:pPr>
+              <a:spcBef>
+                <a:spcPts val="800"/>
+              </a:spcBef>
+              <a:defRPr sz="1800" b="0">
+                <a:solidFill>
+                  <a:srgbClr val="E0E0E0"/>
+                </a:solidFill>
+                <a:latin typeface="Calibri"/>
+              </a:defRPr>
+            </a:pPr>
+            <a:r>
+              <a:t>6. Write tests</a:t>
+            </a:r>
+          </a:p>
+          <a:p>
+            <a:pPr>
+              <a:spcBef>
+                <a:spcPts val="800"/>
+              </a:spcBef>
+              <a:defRPr sz="1800" b="0">
+                <a:solidFill>
+                  <a:srgbClr val="E0E0E0"/>
+                </a:solidFill>
+                <a:latin typeface="Calibri"/>
+              </a:defRPr>
+            </a:pPr>
+            <a:r>
+              <a:t>7. Run tests (Bash)</a:t>
+            </a:r>
+          </a:p>
+          <a:p>
+            <a:pPr>
+              <a:spcBef>
+                <a:spcPts val="800"/>
+              </a:spcBef>
+              <a:defRPr sz="1800" b="0">
+                <a:solidFill>
+                  <a:srgbClr val="E0E0E0"/>
+                </a:solidFill>
+                <a:latin typeface="Calibri"/>
+              </a:defRPr>
+            </a:pPr>
+            <a:r>
+              <a:t>8. Commit &amp; push — then open a PR for review</a:t>
+            </a:r>
+          </a:p>
+          <a:p>
+            <a:pPr>
+              <a:spcBef>
+                <a:spcPts val="800"/>
+              </a:spcBef>
+              <a:defRPr sz="1800" b="0">
+                <a:solidFill>
+                  <a:srgbClr val="E0E0E0"/>
+                </a:solidFill>
+                <a:latin typeface="Calibri"/>
+              </a:defRPr>
+            </a:pPr>
+          </a:p>
+          <a:p>
+            <a:pPr>
+              <a:spcBef>
+                <a:spcPts val="800"/>
+              </a:spcBef>
+              <a:defRPr sz="1800" b="0">
+                <a:solidFill>
+                  <a:srgbClr val="E0E0E0"/>
+                </a:solidFill>
+                <a:latin typeface="Calibri"/>
+              </a:defRPr>
+            </a:pPr>
+            <a:r>
+              <a:t>Branch workflow + CLAUDE.md conventions + hooks + coordination</a:t>
+            </a:r>
+          </a:p>
+        </p:txBody>
+      </p:sp>
+      <p:sp>
+        <p:nvSpPr>
+          <p:cNvPr id="4" name="TextBox 3"/>
+          <p:cNvSpPr txBox="1"/>
+          <p:nvPr/>
+        </p:nvSpPr>
+        <p:spPr>
+          <a:xfrm>
+            <a:off x="548640" y="4389120"/>
+            <a:ext cx="8046720" cy="2286000"/>
+          </a:xfrm>
+          <a:prstGeom prst="rect">
+            <a:avLst/>
+          </a:prstGeom>
+          <a:noFill/>
+        </p:spPr>
+        <p:txBody>
+          <a:bodyPr wrap="square">
+            <a:spAutoFit/>
+          </a:bodyPr>
+          <a:lstStyle/>
+          <a:p/>
+          <a:p>
+            <a:pPr>
+              <a:spcBef>
+                <a:spcPts val="200"/>
+              </a:spcBef>
+              <a:defRPr sz="1400">
+                <a:solidFill>
+                  <a:srgbClr val="E8C47C"/>
+                </a:solidFill>
+                <a:latin typeface="Consolas"/>
+              </a:defRPr>
+            </a:pPr>
+            <a:r>
+              <a:t>"Add a search endpoint for tasks — case-insensitive</a:t>
+            </a:r>
+          </a:p>
+          <a:p>
+            <a:pPr>
+              <a:spcBef>
+                <a:spcPts val="200"/>
+              </a:spcBef>
+              <a:defRPr sz="1400">
+                <a:solidFill>
+                  <a:srgbClr val="E8C47C"/>
+                </a:solidFill>
+                <a:latin typeface="Consolas"/>
+              </a:defRPr>
+            </a:pPr>
+            <a:r>
+              <a:t> substring match on title and description via query</a:t>
+            </a:r>
+          </a:p>
+          <a:p>
+            <a:pPr>
+              <a:spcBef>
+                <a:spcPts val="200"/>
+              </a:spcBef>
+              <a:defRPr sz="1400">
+                <a:solidFill>
+                  <a:srgbClr val="E8C47C"/>
+                </a:solidFill>
+                <a:latin typeface="Consolas"/>
+              </a:defRPr>
+            </a:pPr>
+            <a:r>
+              <a:t> param 'q'. Update database, endpoint, and tests."</a:t>
+            </a:r>
+          </a:p>
+        </p:txBody>
+      </p:sp>
+    </p:spTree>
+  </p:cSld>
+  <p:clrMapOvr>
+    <a:masterClrMapping/>
+  </p:clrMapOvr>
+</p:sld>
+</file>
+
+<file path=ppt/slides/slide32.xml><?xml version="1.0" encoding="utf-8"?>
+<p:sld xmlns:a="http://schemas.openxmlformats.org/drawingml/2006/main" xmlns:p="http://schemas.openxmlformats.org/presentationml/2006/main" xmlns:r="http://schemas.openxmlformats.org/officeDocument/2006/relationships">
+  <p:cSld>
+    <p:bg>
+      <p:bgPr>
+        <a:solidFill>
+          <a:srgbClr val="0F0F1E"/>
+        </a:solidFill>
+        <a:effectLst/>
+      </p:bgPr>
+    </p:bg>
+    <p:spTree>
+      <p:nvGrpSpPr>
+        <p:cNvPr id="1" name=""/>
+        <p:cNvGrpSpPr/>
+        <p:nvPr/>
+      </p:nvGrpSpPr>
+      <p:grpSpPr/>
+      <p:sp>
+        <p:nvSpPr>
+          <p:cNvPr id="2" name="TextBox 1"/>
+          <p:cNvSpPr txBox="1"/>
+          <p:nvPr/>
+        </p:nvSpPr>
+        <p:spPr>
+          <a:xfrm>
+            <a:off x="914400" y="1828800"/>
+            <a:ext cx="7315200" cy="1828800"/>
+          </a:xfrm>
+          <a:prstGeom prst="rect">
+            <a:avLst/>
+          </a:prstGeom>
+          <a:noFill/>
+        </p:spPr>
+        <p:txBody>
+          <a:bodyPr wrap="square">
+            <a:spAutoFit/>
+          </a:bodyPr>
+          <a:lstStyle/>
+          <a:p>
+            <a:pPr algn="ctr">
+              <a:defRPr sz="4000" b="1">
+                <a:solidFill>
+                  <a:srgbClr val="D4A574"/>
+                </a:solidFill>
+                <a:latin typeface="Calibri"/>
+              </a:defRPr>
+            </a:pPr>
+            <a:r>
+              <a:t>Wrap-Up</a:t>
+            </a:r>
+          </a:p>
+        </p:txBody>
+      </p:sp>
+    </p:spTree>
+  </p:cSld>
+  <p:clrMapOvr>
+    <a:masterClrMapping/>
+  </p:clrMapOvr>
+</p:sld>
+</file>
+
+<file path=ppt/slides/slide33.xml><?xml version="1.0" encoding="utf-8"?>
+<p:sld xmlns:a="http://schemas.openxmlformats.org/drawingml/2006/main" xmlns:p="http://schemas.openxmlformats.org/presentationml/2006/main" xmlns:r="http://schemas.openxmlformats.org/officeDocument/2006/relationships">
+  <p:cSld>
+    <p:bg>
+      <p:bgPr>
+        <a:solidFill>
+          <a:srgbClr val="1A1A2E"/>
+        </a:solidFill>
+        <a:effectLst/>
+      </p:bgPr>
+    </p:bg>
+    <p:spTree>
+      <p:nvGrpSpPr>
+        <p:cNvPr id="1" name=""/>
+        <p:cNvGrpSpPr/>
+        <p:nvPr/>
+      </p:nvGrpSpPr>
+      <p:grpSpPr/>
+      <p:sp>
+        <p:nvSpPr>
+          <p:cNvPr id="2" name="TextBox 1"/>
+          <p:cNvSpPr txBox="1"/>
+          <p:nvPr/>
+        </p:nvSpPr>
+        <p:spPr>
+          <a:xfrm>
+            <a:off x="548640" y="365760"/>
+            <a:ext cx="8046720" cy="731520"/>
+          </a:xfrm>
+          <a:prstGeom prst="rect">
+            <a:avLst/>
+          </a:prstGeom>
+          <a:noFill/>
+        </p:spPr>
+        <p:txBody>
+          <a:bodyPr wrap="square">
+            <a:spAutoFit/>
+          </a:bodyPr>
+          <a:lstStyle/>
+          <a:p>
+            <a:pPr>
+              <a:defRPr sz="3200" b="1">
+                <a:solidFill>
+                  <a:srgbClr val="D4A574"/>
+                </a:solidFill>
+                <a:latin typeface="Calibri"/>
+              </a:defRPr>
+            </a:pPr>
+            <a:r>
+              <a:t>Quick Wins to Take Home</a:t>
             </a:r>
           </a:p>
         </p:txBody>
@@ -10428,7 +10561,7 @@
               </a:defRPr>
             </a:pPr>
             <a:r>
-              <a:t>Docs: https://code.claude.com/docs/</a:t>
+              <a:t>Today:</a:t>
             </a:r>
           </a:p>
           <a:p>
@@ -10444,7 +10577,7 @@
               </a:defRPr>
             </a:pPr>
             <a:r>
-              <a:t>Cheat sheet: CHEATSHEET.md in this repo</a:t>
+              <a:t>  1. Add CLAUDE.md to your projects — biggest ROI, 5 minutes</a:t>
             </a:r>
           </a:p>
           <a:p>
@@ -10459,9 +10592,6 @@
                 <a:latin typeface="Calibri"/>
               </a:defRPr>
             </a:pPr>
-            <a:r>
-              <a:t>Report issues: https://github.com/anthropics/claude-code/issues</a:t>
-            </a:r>
           </a:p>
           <a:p>
             <a:pPr>
@@ -10476,7 +10606,7 @@
               </a:defRPr>
             </a:pPr>
             <a:r>
-              <a:t>Exercises: exercises/ directory for self-paced review</a:t>
+              <a:t>This week:</a:t>
             </a:r>
           </a:p>
           <a:p>
@@ -10491,6 +10621,9 @@
                 <a:latin typeface="Calibri"/>
               </a:defRPr>
             </a:pPr>
+            <a:r>
+              <a:t>  2. Configure settings — allow pytest/git, deny rm -rf/.env</a:t>
+            </a:r>
           </a:p>
           <a:p>
             <a:pPr>
@@ -10505,7 +10638,7 @@
               </a:defRPr>
             </a:pPr>
             <a:r>
-              <a:t>Platforms:</a:t>
+              <a:t>  3. Create one skill for your most repeated workflow</a:t>
             </a:r>
           </a:p>
           <a:p>
@@ -10520,8 +10653,53 @@
                 <a:latin typeface="Calibri"/>
               </a:defRPr>
             </a:pPr>
-            <a:r>
-              <a:t>  Terminal  |  VS Code extension  |  JetBrains plugin  |  Web app</a:t>
+          </a:p>
+          <a:p>
+            <a:pPr>
+              <a:spcBef>
+                <a:spcPts val="800"/>
+              </a:spcBef>
+              <a:defRPr sz="1800" b="0">
+                <a:solidFill>
+                  <a:srgbClr val="E0E0E0"/>
+                </a:solidFill>
+                <a:latin typeface="Calibri"/>
+              </a:defRPr>
+            </a:pPr>
+            <a:r>
+              <a:t>This month:</a:t>
+            </a:r>
+          </a:p>
+          <a:p>
+            <a:pPr>
+              <a:spcBef>
+                <a:spcPts val="800"/>
+              </a:spcBef>
+              <a:defRPr sz="1800" b="0">
+                <a:solidFill>
+                  <a:srgbClr val="E0E0E0"/>
+                </a:solidFill>
+                <a:latin typeface="Calibri"/>
+              </a:defRPr>
+            </a:pPr>
+            <a:r>
+              <a:t>  4. Add hooks — auto-format, secret detection</a:t>
+            </a:r>
+          </a:p>
+          <a:p>
+            <a:pPr>
+              <a:spcBef>
+                <a:spcPts val="800"/>
+              </a:spcBef>
+              <a:defRPr sz="1800" b="0">
+                <a:solidFill>
+                  <a:srgbClr val="E0E0E0"/>
+                </a:solidFill>
+                <a:latin typeface="Calibri"/>
+              </a:defRPr>
+            </a:pPr>
+            <a:r>
+              <a:t>  5. Create custom agents for your team's review/research needs</a:t>
             </a:r>
           </a:p>
         </p:txBody>
@@ -10534,7 +10712,882 @@
 </p:sld>
 </file>
 
-<file path=ppt/slides/slide32.xml><?xml version="1.0" encoding="utf-8"?>
+<file path=ppt/slides/slide34.xml><?xml version="1.0" encoding="utf-8"?>
+<p:sld xmlns:a="http://schemas.openxmlformats.org/drawingml/2006/main" xmlns:p="http://schemas.openxmlformats.org/presentationml/2006/main" xmlns:r="http://schemas.openxmlformats.org/officeDocument/2006/relationships">
+  <p:cSld>
+    <p:bg>
+      <p:bgPr>
+        <a:solidFill>
+          <a:srgbClr val="1A1A2E"/>
+        </a:solidFill>
+        <a:effectLst/>
+      </p:bgPr>
+    </p:bg>
+    <p:spTree>
+      <p:nvGrpSpPr>
+        <p:cNvPr id="1" name=""/>
+        <p:cNvGrpSpPr/>
+        <p:nvPr/>
+      </p:nvGrpSpPr>
+      <p:grpSpPr/>
+      <p:sp>
+        <p:nvSpPr>
+          <p:cNvPr id="2" name="TextBox 1"/>
+          <p:cNvSpPr txBox="1"/>
+          <p:nvPr/>
+        </p:nvSpPr>
+        <p:spPr>
+          <a:xfrm>
+            <a:off x="548640" y="365760"/>
+            <a:ext cx="8046720" cy="731520"/>
+          </a:xfrm>
+          <a:prstGeom prst="rect">
+            <a:avLst/>
+          </a:prstGeom>
+          <a:noFill/>
+        </p:spPr>
+        <p:txBody>
+          <a:bodyPr wrap="square">
+            <a:spAutoFit/>
+          </a:bodyPr>
+          <a:lstStyle/>
+          <a:p>
+            <a:pPr>
+              <a:defRPr sz="3200" b="1">
+                <a:solidFill>
+                  <a:srgbClr val="D4A574"/>
+                </a:solidFill>
+                <a:latin typeface="Calibri"/>
+              </a:defRPr>
+            </a:pPr>
+            <a:r>
+              <a:t>The Configuration Landscape</a:t>
+            </a:r>
+          </a:p>
+        </p:txBody>
+      </p:sp>
+      <p:graphicFrame>
+        <p:nvGraphicFramePr>
+          <p:cNvPr id="3" name="Table 2"/>
+          <p:cNvGraphicFramePr>
+            <a:graphicFrameLocks noGrp="1"/>
+          </p:cNvGraphicFramePr>
+          <p:nvPr/>
+        </p:nvGraphicFramePr>
+        <p:xfrm>
+          <a:off x="548640" y="1280160"/>
+          <a:ext cx="8046720" cy="3291840"/>
+        </p:xfrm>
+        <a:graphic>
+          <a:graphicData uri="http://schemas.openxmlformats.org/drawingml/2006/table">
+            <a:tbl>
+              <a:tblPr firstRow="1" bandRow="1">
+                <a:tableStyleId>{5C22544A-7EE6-4342-B048-85BDC9FD1C3A}</a:tableStyleId>
+              </a:tblPr>
+              <a:tblGrid>
+                <a:gridCol w="2682240"/>
+                <a:gridCol w="2682240"/>
+                <a:gridCol w="2682240"/>
+              </a:tblGrid>
+              <a:tr h="411480">
+                <a:tc>
+                  <a:txBody>
+                    <a:bodyPr/>
+                    <a:lstStyle/>
+                    <a:p>
+                      <a:pPr>
+                        <a:defRPr sz="1400" b="1">
+                          <a:solidFill>
+                            <a:srgbClr val="D4A574"/>
+                          </a:solidFill>
+                          <a:latin typeface="Calibri"/>
+                        </a:defRPr>
+                      </a:pPr>
+                      <a:r>
+                        <a:t>Feature</a:t>
+                      </a:r>
+                    </a:p>
+                  </a:txBody>
+                  <a:tcPr>
+                    <a:solidFill>
+                      <a:srgbClr val="2D2D44"/>
+                    </a:solidFill>
+                  </a:tcPr>
+                </a:tc>
+                <a:tc>
+                  <a:txBody>
+                    <a:bodyPr/>
+                    <a:lstStyle/>
+                    <a:p>
+                      <a:pPr>
+                        <a:defRPr sz="1400" b="1">
+                          <a:solidFill>
+                            <a:srgbClr val="D4A574"/>
+                          </a:solidFill>
+                          <a:latin typeface="Calibri"/>
+                        </a:defRPr>
+                      </a:pPr>
+                      <a:r>
+                        <a:t>File</a:t>
+                      </a:r>
+                    </a:p>
+                  </a:txBody>
+                  <a:tcPr>
+                    <a:solidFill>
+                      <a:srgbClr val="2D2D44"/>
+                    </a:solidFill>
+                  </a:tcPr>
+                </a:tc>
+                <a:tc>
+                  <a:txBody>
+                    <a:bodyPr/>
+                    <a:lstStyle/>
+                    <a:p>
+                      <a:pPr>
+                        <a:defRPr sz="1400" b="1">
+                          <a:solidFill>
+                            <a:srgbClr val="D4A574"/>
+                          </a:solidFill>
+                          <a:latin typeface="Calibri"/>
+                        </a:defRPr>
+                      </a:pPr>
+                      <a:r>
+                        <a:t>Guides vs Enforces</a:t>
+                      </a:r>
+                    </a:p>
+                  </a:txBody>
+                  <a:tcPr>
+                    <a:solidFill>
+                      <a:srgbClr val="2D2D44"/>
+                    </a:solidFill>
+                  </a:tcPr>
+                </a:tc>
+              </a:tr>
+              <a:tr h="411480">
+                <a:tc>
+                  <a:txBody>
+                    <a:bodyPr/>
+                    <a:lstStyle/>
+                    <a:p>
+                      <a:pPr>
+                        <a:defRPr sz="1300">
+                          <a:solidFill>
+                            <a:srgbClr val="E0E0E0"/>
+                          </a:solidFill>
+                          <a:latin typeface="Calibri"/>
+                        </a:defRPr>
+                      </a:pPr>
+                      <a:r>
+                        <a:t>CLAUDE.md</a:t>
+                      </a:r>
+                    </a:p>
+                  </a:txBody>
+                  <a:tcPr>
+                    <a:solidFill>
+                      <a:srgbClr val="1E1E36"/>
+                    </a:solidFill>
+                  </a:tcPr>
+                </a:tc>
+                <a:tc>
+                  <a:txBody>
+                    <a:bodyPr/>
+                    <a:lstStyle/>
+                    <a:p>
+                      <a:pPr>
+                        <a:defRPr sz="1300">
+                          <a:solidFill>
+                            <a:srgbClr val="E0E0E0"/>
+                          </a:solidFill>
+                          <a:latin typeface="Calibri"/>
+                        </a:defRPr>
+                      </a:pPr>
+                      <a:r>
+                        <a:t>./CLAUDE.md</a:t>
+                      </a:r>
+                    </a:p>
+                  </a:txBody>
+                  <a:tcPr>
+                    <a:solidFill>
+                      <a:srgbClr val="1E1E36"/>
+                    </a:solidFill>
+                  </a:tcPr>
+                </a:tc>
+                <a:tc>
+                  <a:txBody>
+                    <a:bodyPr/>
+                    <a:lstStyle/>
+                    <a:p>
+                      <a:pPr>
+                        <a:defRPr sz="1300">
+                          <a:solidFill>
+                            <a:srgbClr val="E0E0E0"/>
+                          </a:solidFill>
+                          <a:latin typeface="Calibri"/>
+                        </a:defRPr>
+                      </a:pPr>
+                      <a:r>
+                        <a:t>Guides</a:t>
+                      </a:r>
+                    </a:p>
+                  </a:txBody>
+                  <a:tcPr>
+                    <a:solidFill>
+                      <a:srgbClr val="1E1E36"/>
+                    </a:solidFill>
+                  </a:tcPr>
+                </a:tc>
+              </a:tr>
+              <a:tr h="411480">
+                <a:tc>
+                  <a:txBody>
+                    <a:bodyPr/>
+                    <a:lstStyle/>
+                    <a:p>
+                      <a:pPr>
+                        <a:defRPr sz="1300">
+                          <a:solidFill>
+                            <a:srgbClr val="E0E0E0"/>
+                          </a:solidFill>
+                          <a:latin typeface="Calibri"/>
+                        </a:defRPr>
+                      </a:pPr>
+                      <a:r>
+                        <a:t>Settings</a:t>
+                      </a:r>
+                    </a:p>
+                  </a:txBody>
+                  <a:tcPr>
+                    <a:solidFill>
+                      <a:srgbClr val="1E1E36"/>
+                    </a:solidFill>
+                  </a:tcPr>
+                </a:tc>
+                <a:tc>
+                  <a:txBody>
+                    <a:bodyPr/>
+                    <a:lstStyle/>
+                    <a:p>
+                      <a:pPr>
+                        <a:defRPr sz="1300">
+                          <a:solidFill>
+                            <a:srgbClr val="E0E0E0"/>
+                          </a:solidFill>
+                          <a:latin typeface="Calibri"/>
+                        </a:defRPr>
+                      </a:pPr>
+                      <a:r>
+                        <a:t>.claude/settings.json</a:t>
+                      </a:r>
+                    </a:p>
+                  </a:txBody>
+                  <a:tcPr>
+                    <a:solidFill>
+                      <a:srgbClr val="1E1E36"/>
+                    </a:solidFill>
+                  </a:tcPr>
+                </a:tc>
+                <a:tc>
+                  <a:txBody>
+                    <a:bodyPr/>
+                    <a:lstStyle/>
+                    <a:p>
+                      <a:pPr>
+                        <a:defRPr sz="1300">
+                          <a:solidFill>
+                            <a:srgbClr val="E0E0E0"/>
+                          </a:solidFill>
+                          <a:latin typeface="Calibri"/>
+                        </a:defRPr>
+                      </a:pPr>
+                      <a:r>
+                        <a:t>Enforces</a:t>
+                      </a:r>
+                    </a:p>
+                  </a:txBody>
+                  <a:tcPr>
+                    <a:solidFill>
+                      <a:srgbClr val="1E1E36"/>
+                    </a:solidFill>
+                  </a:tcPr>
+                </a:tc>
+              </a:tr>
+              <a:tr h="411480">
+                <a:tc>
+                  <a:txBody>
+                    <a:bodyPr/>
+                    <a:lstStyle/>
+                    <a:p>
+                      <a:pPr>
+                        <a:defRPr sz="1300">
+                          <a:solidFill>
+                            <a:srgbClr val="E0E0E0"/>
+                          </a:solidFill>
+                          <a:latin typeface="Calibri"/>
+                        </a:defRPr>
+                      </a:pPr>
+                      <a:r>
+                        <a:t>Hooks</a:t>
+                      </a:r>
+                    </a:p>
+                  </a:txBody>
+                  <a:tcPr>
+                    <a:solidFill>
+                      <a:srgbClr val="1E1E36"/>
+                    </a:solidFill>
+                  </a:tcPr>
+                </a:tc>
+                <a:tc>
+                  <a:txBody>
+                    <a:bodyPr/>
+                    <a:lstStyle/>
+                    <a:p>
+                      <a:pPr>
+                        <a:defRPr sz="1300">
+                          <a:solidFill>
+                            <a:srgbClr val="E0E0E0"/>
+                          </a:solidFill>
+                          <a:latin typeface="Calibri"/>
+                        </a:defRPr>
+                      </a:pPr>
+                      <a:r>
+                        <a:t>In settings.json</a:t>
+                      </a:r>
+                    </a:p>
+                  </a:txBody>
+                  <a:tcPr>
+                    <a:solidFill>
+                      <a:srgbClr val="1E1E36"/>
+                    </a:solidFill>
+                  </a:tcPr>
+                </a:tc>
+                <a:tc>
+                  <a:txBody>
+                    <a:bodyPr/>
+                    <a:lstStyle/>
+                    <a:p>
+                      <a:pPr>
+                        <a:defRPr sz="1300">
+                          <a:solidFill>
+                            <a:srgbClr val="E0E0E0"/>
+                          </a:solidFill>
+                          <a:latin typeface="Calibri"/>
+                        </a:defRPr>
+                      </a:pPr>
+                      <a:r>
+                        <a:t>Enforces</a:t>
+                      </a:r>
+                    </a:p>
+                  </a:txBody>
+                  <a:tcPr>
+                    <a:solidFill>
+                      <a:srgbClr val="1E1E36"/>
+                    </a:solidFill>
+                  </a:tcPr>
+                </a:tc>
+              </a:tr>
+              <a:tr h="411480">
+                <a:tc>
+                  <a:txBody>
+                    <a:bodyPr/>
+                    <a:lstStyle/>
+                    <a:p>
+                      <a:pPr>
+                        <a:defRPr sz="1300">
+                          <a:solidFill>
+                            <a:srgbClr val="E0E0E0"/>
+                          </a:solidFill>
+                          <a:latin typeface="Calibri"/>
+                        </a:defRPr>
+                      </a:pPr>
+                      <a:r>
+                        <a:t>Skills</a:t>
+                      </a:r>
+                    </a:p>
+                  </a:txBody>
+                  <a:tcPr>
+                    <a:solidFill>
+                      <a:srgbClr val="1E1E36"/>
+                    </a:solidFill>
+                  </a:tcPr>
+                </a:tc>
+                <a:tc>
+                  <a:txBody>
+                    <a:bodyPr/>
+                    <a:lstStyle/>
+                    <a:p>
+                      <a:pPr>
+                        <a:defRPr sz="1300">
+                          <a:solidFill>
+                            <a:srgbClr val="E0E0E0"/>
+                          </a:solidFill>
+                          <a:latin typeface="Calibri"/>
+                        </a:defRPr>
+                      </a:pPr>
+                      <a:r>
+                        <a:t>.claude/skills/*/SKILL.md</a:t>
+                      </a:r>
+                    </a:p>
+                  </a:txBody>
+                  <a:tcPr>
+                    <a:solidFill>
+                      <a:srgbClr val="1E1E36"/>
+                    </a:solidFill>
+                  </a:tcPr>
+                </a:tc>
+                <a:tc>
+                  <a:txBody>
+                    <a:bodyPr/>
+                    <a:lstStyle/>
+                    <a:p>
+                      <a:pPr>
+                        <a:defRPr sz="1300">
+                          <a:solidFill>
+                            <a:srgbClr val="E0E0E0"/>
+                          </a:solidFill>
+                          <a:latin typeface="Calibri"/>
+                        </a:defRPr>
+                      </a:pPr>
+                      <a:r>
+                        <a:t>Guides</a:t>
+                      </a:r>
+                    </a:p>
+                  </a:txBody>
+                  <a:tcPr>
+                    <a:solidFill>
+                      <a:srgbClr val="1E1E36"/>
+                    </a:solidFill>
+                  </a:tcPr>
+                </a:tc>
+              </a:tr>
+              <a:tr h="411480">
+                <a:tc>
+                  <a:txBody>
+                    <a:bodyPr/>
+                    <a:lstStyle/>
+                    <a:p>
+                      <a:pPr>
+                        <a:defRPr sz="1300">
+                          <a:solidFill>
+                            <a:srgbClr val="E0E0E0"/>
+                          </a:solidFill>
+                          <a:latin typeface="Calibri"/>
+                        </a:defRPr>
+                      </a:pPr>
+                      <a:r>
+                        <a:t>Agents</a:t>
+                      </a:r>
+                    </a:p>
+                  </a:txBody>
+                  <a:tcPr>
+                    <a:solidFill>
+                      <a:srgbClr val="1E1E36"/>
+                    </a:solidFill>
+                  </a:tcPr>
+                </a:tc>
+                <a:tc>
+                  <a:txBody>
+                    <a:bodyPr/>
+                    <a:lstStyle/>
+                    <a:p>
+                      <a:pPr>
+                        <a:defRPr sz="1300">
+                          <a:solidFill>
+                            <a:srgbClr val="E0E0E0"/>
+                          </a:solidFill>
+                          <a:latin typeface="Calibri"/>
+                        </a:defRPr>
+                      </a:pPr>
+                      <a:r>
+                        <a:t>.claude/agents/*.md</a:t>
+                      </a:r>
+                    </a:p>
+                  </a:txBody>
+                  <a:tcPr>
+                    <a:solidFill>
+                      <a:srgbClr val="1E1E36"/>
+                    </a:solidFill>
+                  </a:tcPr>
+                </a:tc>
+                <a:tc>
+                  <a:txBody>
+                    <a:bodyPr/>
+                    <a:lstStyle/>
+                    <a:p>
+                      <a:pPr>
+                        <a:defRPr sz="1300">
+                          <a:solidFill>
+                            <a:srgbClr val="E0E0E0"/>
+                          </a:solidFill>
+                          <a:latin typeface="Calibri"/>
+                        </a:defRPr>
+                      </a:pPr>
+                      <a:r>
+                        <a:t>Both</a:t>
+                      </a:r>
+                    </a:p>
+                  </a:txBody>
+                  <a:tcPr>
+                    <a:solidFill>
+                      <a:srgbClr val="1E1E36"/>
+                    </a:solidFill>
+                  </a:tcPr>
+                </a:tc>
+              </a:tr>
+              <a:tr h="411480">
+                <a:tc>
+                  <a:txBody>
+                    <a:bodyPr/>
+                    <a:lstStyle/>
+                    <a:p>
+                      <a:pPr>
+                        <a:defRPr sz="1300">
+                          <a:solidFill>
+                            <a:srgbClr val="E0E0E0"/>
+                          </a:solidFill>
+                          <a:latin typeface="Calibri"/>
+                        </a:defRPr>
+                      </a:pPr>
+                      <a:r>
+                        <a:t>MCP</a:t>
+                      </a:r>
+                    </a:p>
+                  </a:txBody>
+                  <a:tcPr>
+                    <a:solidFill>
+                      <a:srgbClr val="1E1E36"/>
+                    </a:solidFill>
+                  </a:tcPr>
+                </a:tc>
+                <a:tc>
+                  <a:txBody>
+                    <a:bodyPr/>
+                    <a:lstStyle/>
+                    <a:p>
+                      <a:pPr>
+                        <a:defRPr sz="1300">
+                          <a:solidFill>
+                            <a:srgbClr val="E0E0E0"/>
+                          </a:solidFill>
+                          <a:latin typeface="Calibri"/>
+                        </a:defRPr>
+                      </a:pPr>
+                      <a:r>
+                        <a:t>.mcp.json</a:t>
+                      </a:r>
+                    </a:p>
+                  </a:txBody>
+                  <a:tcPr>
+                    <a:solidFill>
+                      <a:srgbClr val="1E1E36"/>
+                    </a:solidFill>
+                  </a:tcPr>
+                </a:tc>
+                <a:tc>
+                  <a:txBody>
+                    <a:bodyPr/>
+                    <a:lstStyle/>
+                    <a:p>
+                      <a:pPr>
+                        <a:defRPr sz="1300">
+                          <a:solidFill>
+                            <a:srgbClr val="E0E0E0"/>
+                          </a:solidFill>
+                          <a:latin typeface="Calibri"/>
+                        </a:defRPr>
+                      </a:pPr>
+                      <a:r>
+                        <a:t>Extends</a:t>
+                      </a:r>
+                    </a:p>
+                  </a:txBody>
+                  <a:tcPr>
+                    <a:solidFill>
+                      <a:srgbClr val="1E1E36"/>
+                    </a:solidFill>
+                  </a:tcPr>
+                </a:tc>
+              </a:tr>
+              <a:tr h="411480">
+                <a:tc>
+                  <a:txBody>
+                    <a:bodyPr/>
+                    <a:lstStyle/>
+                    <a:p>
+                      <a:pPr>
+                        <a:defRPr sz="1300">
+                          <a:solidFill>
+                            <a:srgbClr val="E0E0E0"/>
+                          </a:solidFill>
+                          <a:latin typeface="Calibri"/>
+                        </a:defRPr>
+                      </a:pPr>
+                      <a:r>
+                        <a:t>Memory</a:t>
+                      </a:r>
+                    </a:p>
+                  </a:txBody>
+                  <a:tcPr>
+                    <a:solidFill>
+                      <a:srgbClr val="1E1E36"/>
+                    </a:solidFill>
+                  </a:tcPr>
+                </a:tc>
+                <a:tc>
+                  <a:txBody>
+                    <a:bodyPr/>
+                    <a:lstStyle/>
+                    <a:p>
+                      <a:pPr>
+                        <a:defRPr sz="1300">
+                          <a:solidFill>
+                            <a:srgbClr val="E0E0E0"/>
+                          </a:solidFill>
+                          <a:latin typeface="Calibri"/>
+                        </a:defRPr>
+                      </a:pPr>
+                      <a:r>
+                        <a:t>~/.claude/projects/*/memory/</a:t>
+                      </a:r>
+                    </a:p>
+                  </a:txBody>
+                  <a:tcPr>
+                    <a:solidFill>
+                      <a:srgbClr val="1E1E36"/>
+                    </a:solidFill>
+                  </a:tcPr>
+                </a:tc>
+                <a:tc>
+                  <a:txBody>
+                    <a:bodyPr/>
+                    <a:lstStyle/>
+                    <a:p>
+                      <a:pPr>
+                        <a:defRPr sz="1300">
+                          <a:solidFill>
+                            <a:srgbClr val="E0E0E0"/>
+                          </a:solidFill>
+                          <a:latin typeface="Calibri"/>
+                        </a:defRPr>
+                      </a:pPr>
+                      <a:r>
+                        <a:t>Persists</a:t>
+                      </a:r>
+                    </a:p>
+                  </a:txBody>
+                  <a:tcPr>
+                    <a:solidFill>
+                      <a:srgbClr val="1E1E36"/>
+                    </a:solidFill>
+                  </a:tcPr>
+                </a:tc>
+              </a:tr>
+            </a:tbl>
+          </a:graphicData>
+        </a:graphic>
+      </p:graphicFrame>
+    </p:spTree>
+  </p:cSld>
+  <p:clrMapOvr>
+    <a:masterClrMapping/>
+  </p:clrMapOvr>
+</p:sld>
+</file>
+
+<file path=ppt/slides/slide35.xml><?xml version="1.0" encoding="utf-8"?>
+<p:sld xmlns:a="http://schemas.openxmlformats.org/drawingml/2006/main" xmlns:p="http://schemas.openxmlformats.org/presentationml/2006/main" xmlns:r="http://schemas.openxmlformats.org/officeDocument/2006/relationships">
+  <p:cSld>
+    <p:bg>
+      <p:bgPr>
+        <a:solidFill>
+          <a:srgbClr val="1A1A2E"/>
+        </a:solidFill>
+        <a:effectLst/>
+      </p:bgPr>
+    </p:bg>
+    <p:spTree>
+      <p:nvGrpSpPr>
+        <p:cNvPr id="1" name=""/>
+        <p:cNvGrpSpPr/>
+        <p:nvPr/>
+      </p:nvGrpSpPr>
+      <p:grpSpPr/>
+      <p:sp>
+        <p:nvSpPr>
+          <p:cNvPr id="2" name="TextBox 1"/>
+          <p:cNvSpPr txBox="1"/>
+          <p:nvPr/>
+        </p:nvSpPr>
+        <p:spPr>
+          <a:xfrm>
+            <a:off x="548640" y="365760"/>
+            <a:ext cx="8046720" cy="731520"/>
+          </a:xfrm>
+          <a:prstGeom prst="rect">
+            <a:avLst/>
+          </a:prstGeom>
+          <a:noFill/>
+        </p:spPr>
+        <p:txBody>
+          <a:bodyPr wrap="square">
+            <a:spAutoFit/>
+          </a:bodyPr>
+          <a:lstStyle/>
+          <a:p>
+            <a:pPr>
+              <a:defRPr sz="3200" b="1">
+                <a:solidFill>
+                  <a:srgbClr val="D4A574"/>
+                </a:solidFill>
+                <a:latin typeface="Calibri"/>
+              </a:defRPr>
+            </a:pPr>
+            <a:r>
+              <a:t>Resources</a:t>
+            </a:r>
+          </a:p>
+        </p:txBody>
+      </p:sp>
+      <p:sp>
+        <p:nvSpPr>
+          <p:cNvPr id="3" name="TextBox 2"/>
+          <p:cNvSpPr txBox="1"/>
+          <p:nvPr/>
+        </p:nvSpPr>
+        <p:spPr>
+          <a:xfrm>
+            <a:off x="548640" y="1188720"/>
+            <a:ext cx="8046720" cy="5029200"/>
+          </a:xfrm>
+          <a:prstGeom prst="rect">
+            <a:avLst/>
+          </a:prstGeom>
+          <a:noFill/>
+        </p:spPr>
+        <p:txBody>
+          <a:bodyPr wrap="square">
+            <a:spAutoFit/>
+          </a:bodyPr>
+          <a:lstStyle/>
+          <a:p>
+            <a:pPr>
+              <a:spcBef>
+                <a:spcPts val="400"/>
+              </a:spcBef>
+              <a:defRPr sz="1800">
+                <a:solidFill>
+                  <a:srgbClr val="E0E0E0"/>
+                </a:solidFill>
+                <a:latin typeface="Calibri"/>
+              </a:defRPr>
+            </a:pPr>
+            <a:r>
+              <a:t>Docs: https://code.claude.com/docs/</a:t>
+            </a:r>
+          </a:p>
+          <a:p>
+            <a:pPr>
+              <a:spcBef>
+                <a:spcPts val="800"/>
+              </a:spcBef>
+              <a:defRPr sz="1800" b="0">
+                <a:solidFill>
+                  <a:srgbClr val="E0E0E0"/>
+                </a:solidFill>
+                <a:latin typeface="Calibri"/>
+              </a:defRPr>
+            </a:pPr>
+            <a:r>
+              <a:t>Cheat sheet: CHEATSHEET.md in this repo</a:t>
+            </a:r>
+          </a:p>
+          <a:p>
+            <a:pPr>
+              <a:spcBef>
+                <a:spcPts val="800"/>
+              </a:spcBef>
+              <a:defRPr sz="1800" b="0">
+                <a:solidFill>
+                  <a:srgbClr val="E0E0E0"/>
+                </a:solidFill>
+                <a:latin typeface="Calibri"/>
+              </a:defRPr>
+            </a:pPr>
+            <a:r>
+              <a:t>Report issues: https://github.com/anthropics/claude-code/issues</a:t>
+            </a:r>
+          </a:p>
+          <a:p>
+            <a:pPr>
+              <a:spcBef>
+                <a:spcPts val="800"/>
+              </a:spcBef>
+              <a:defRPr sz="1800" b="0">
+                <a:solidFill>
+                  <a:srgbClr val="E0E0E0"/>
+                </a:solidFill>
+                <a:latin typeface="Calibri"/>
+              </a:defRPr>
+            </a:pPr>
+            <a:r>
+              <a:t>Exercises: exercises/ directory for self-paced review</a:t>
+            </a:r>
+          </a:p>
+          <a:p>
+            <a:pPr>
+              <a:spcBef>
+                <a:spcPts val="800"/>
+              </a:spcBef>
+              <a:defRPr sz="1800" b="0">
+                <a:solidFill>
+                  <a:srgbClr val="E0E0E0"/>
+                </a:solidFill>
+                <a:latin typeface="Calibri"/>
+              </a:defRPr>
+            </a:pPr>
+          </a:p>
+          <a:p>
+            <a:pPr>
+              <a:spcBef>
+                <a:spcPts val="800"/>
+              </a:spcBef>
+              <a:defRPr sz="1800" b="0">
+                <a:solidFill>
+                  <a:srgbClr val="E0E0E0"/>
+                </a:solidFill>
+                <a:latin typeface="Calibri"/>
+              </a:defRPr>
+            </a:pPr>
+            <a:r>
+              <a:t>Platforms:</a:t>
+            </a:r>
+          </a:p>
+          <a:p>
+            <a:pPr>
+              <a:spcBef>
+                <a:spcPts val="800"/>
+              </a:spcBef>
+              <a:defRPr sz="1800" b="0">
+                <a:solidFill>
+                  <a:srgbClr val="E0E0E0"/>
+                </a:solidFill>
+                <a:latin typeface="Calibri"/>
+              </a:defRPr>
+            </a:pPr>
+            <a:r>
+              <a:t>  Terminal  |  VS Code extension  |  JetBrains plugin  |  Web app</a:t>
+            </a:r>
+          </a:p>
+        </p:txBody>
+      </p:sp>
+    </p:spTree>
+  </p:cSld>
+  <p:clrMapOvr>
+    <a:masterClrMapping/>
+  </p:clrMapOvr>
+</p:sld>
+</file>
+
+<file path=ppt/slides/slide36.xml><?xml version="1.0" encoding="utf-8"?>
 <p:sld xmlns:a="http://schemas.openxmlformats.org/drawingml/2006/main" xmlns:p="http://schemas.openxmlformats.org/presentationml/2006/main" xmlns:r="http://schemas.openxmlformats.org/officeDocument/2006/relationships">
   <p:cSld>
     <p:bg>
@@ -11876,7 +12929,7 @@
               </a:defRPr>
             </a:pPr>
             <a:r>
-              <a:t>Context Management</a:t>
+              <a:t>Essential Session Commands</a:t>
             </a:r>
           </a:p>
         </p:txBody>
@@ -11891,7 +12944,7 @@
         </p:nvGraphicFramePr>
         <p:xfrm>
           <a:off x="548640" y="1280160"/>
-          <a:ext cx="8046720" cy="1645920"/>
+          <a:ext cx="8046720" cy="2468880"/>
         </p:xfrm>
         <a:graphic>
           <a:graphicData uri="http://schemas.openxmlformats.org/drawingml/2006/table">
@@ -11968,6 +13021,56 @@
                         </a:defRPr>
                       </a:pPr>
                       <a:r>
+                        <a:t>/context</a:t>
+                      </a:r>
+                    </a:p>
+                  </a:txBody>
+                  <a:tcPr>
+                    <a:solidFill>
+                      <a:srgbClr val="1E1E36"/>
+                    </a:solidFill>
+                  </a:tcPr>
+                </a:tc>
+                <a:tc>
+                  <a:txBody>
+                    <a:bodyPr/>
+                    <a:lstStyle/>
+                    <a:p>
+                      <a:pPr>
+                        <a:defRPr sz="1300">
+                          <a:solidFill>
+                            <a:srgbClr val="E0E0E0"/>
+                          </a:solidFill>
+                          <a:latin typeface="Calibri"/>
+                        </a:defRPr>
+                      </a:pPr>
+                      <a:r>
+                        <a:t>Show context window usage (%)</a:t>
+                      </a:r>
+                    </a:p>
+                  </a:txBody>
+                  <a:tcPr>
+                    <a:solidFill>
+                      <a:srgbClr val="1E1E36"/>
+                    </a:solidFill>
+                  </a:tcPr>
+                </a:tc>
+              </a:tr>
+              <a:tr h="411480">
+                <a:tc>
+                  <a:txBody>
+                    <a:bodyPr/>
+                    <a:lstStyle/>
+                    <a:p>
+                      <a:pPr>
+                        <a:defRPr sz="1300">
+                          <a:solidFill>
+                            <a:srgbClr val="E0E0E0"/>
+                          </a:solidFill>
+                          <a:latin typeface="Calibri"/>
+                        </a:defRPr>
+                      </a:pPr>
+                      <a:r>
                         <a:t>/compact</a:t>
                       </a:r>
                     </a:p>
@@ -11992,7 +13095,57 @@
                         </a:defRPr>
                       </a:pPr>
                       <a:r>
-                        <a:t>Summarize conversation, free up space</a:t>
+                        <a:t>Summarize history, free up space</a:t>
+                      </a:r>
+                    </a:p>
+                  </a:txBody>
+                  <a:tcPr>
+                    <a:solidFill>
+                      <a:srgbClr val="1E1E36"/>
+                    </a:solidFill>
+                  </a:tcPr>
+                </a:tc>
+              </a:tr>
+              <a:tr h="411480">
+                <a:tc>
+                  <a:txBody>
+                    <a:bodyPr/>
+                    <a:lstStyle/>
+                    <a:p>
+                      <a:pPr>
+                        <a:defRPr sz="1300">
+                          <a:solidFill>
+                            <a:srgbClr val="E0E0E0"/>
+                          </a:solidFill>
+                          <a:latin typeface="Calibri"/>
+                        </a:defRPr>
+                      </a:pPr>
+                      <a:r>
+                        <a:t>/memory</a:t>
+                      </a:r>
+                    </a:p>
+                  </a:txBody>
+                  <a:tcPr>
+                    <a:solidFill>
+                      <a:srgbClr val="1E1E36"/>
+                    </a:solidFill>
+                  </a:tcPr>
+                </a:tc>
+                <a:tc>
+                  <a:txBody>
+                    <a:bodyPr/>
+                    <a:lstStyle/>
+                    <a:p>
+                      <a:pPr>
+                        <a:defRPr sz="1300">
+                          <a:solidFill>
+                            <a:srgbClr val="E0E0E0"/>
+                          </a:solidFill>
+                          <a:latin typeface="Calibri"/>
+                        </a:defRPr>
+                      </a:pPr>
+                      <a:r>
+                        <a:t>View / edit persistent memory</a:t>
                       </a:r>
                     </a:p>
                   </a:txBody>

</xml_diff>